<commit_message>
Requirements Engineering: RE-Rolle ArenaOne veröffentlicht (Spezifikation v0.6, Präsentation, Ermittlung, KI-Experiment mit App), Stakeholder-Decks aktualisiert
</commit_message>
<xml_diff>
--- a/requirements-engineering/RE_Projektvorstellung_Postverarbeitung.pptx
+++ b/requirements-engineering/RE_Projektvorstellung_Postverarbeitung.pptx
@@ -114,25 +114,25 @@
   <p:extLst>
     <p:ext uri="{521415D9-36F7-43E2-AB2F-B90AF26B5E84}">
       <p14:sectionLst xmlns:p14="http://schemas.microsoft.com/office/powerpoint/2010/main">
-        <p14:section name="Einstieg" id="{7b74e929-6175-a271-e638-fee08a252645}">
+        <p14:section name="Einstieg" id="{486af42b-f60f-71ac-d5ff-25b5e5111113}">
           <p14:sldIdLst>
             <p14:sldId id="256"/>
           </p14:sldIdLst>
         </p14:section>
-        <p14:section name="Ausgangslage" id="{d2f51ec0-3994-0eb2-62c8-d53c975f2a0a}">
+        <p14:section name="Ausgangslage" id="{3ceebf98-7a61-4e3c-2be7-2e4e378a9d32}">
           <p14:sldIdLst>
             <p14:sldId id="257"/>
             <p14:sldId id="258"/>
             <p14:sldId id="259"/>
           </p14:sldIdLst>
         </p14:section>
-        <p14:section name="Vision" id="{ffb24c3d-04ee-a7d4-03ac-59dd4eeca939}">
+        <p14:section name="Vision" id="{16ed15d6-293b-abac-3014-0803b743efdc}">
           <p14:sldIdLst>
             <p14:sldId id="260"/>
             <p14:sldId id="261"/>
           </p14:sldIdLst>
         </p14:section>
-        <p14:section name="Auftrag" id="{bb781fc5-038d-b3bb-5029-f4c4b9759553}">
+        <p14:section name="Auftrag" id="{b505c8a9-cc81-0183-ce10-2110e37d4377}">
           <p14:sldIdLst>
             <p14:sldId id="262"/>
             <p14:sldId id="263"/>
@@ -2027,7 +2027,7 @@
                   <a:schemeClr val="accent6"/>
                 </a:solidFill>
               </a:rPr>
-              <a:t>Requirements Engineering HS26 · PVA 2 · Gruppe 9 · [Name 1], [Name 2], [Name 3]</a:t>
+              <a:t>Requirements Engineering HS26 · PVA 2 · Gruppe 9 · Görkem Taspinar, Ardian Ibrahimaj</a:t>
             </a:r>
             <a:endParaRPr lang="en-US" sz="1200" dirty="0"/>
           </a:p>
@@ -9301,7 +9301,7 @@
                   <a:schemeClr val="accent6"/>
                 </a:solidFill>
               </a:rPr>
-              <a:t>Gruppe 9 · [Name 1], [Name 2], [Name 3] · Kontakt: [E-Mail]</a:t>
+              <a:t>Gruppe 9 · Görkem Taspinar, Ardian Ibrahimaj · Kontakt: [E-Mail]</a:t>
             </a:r>
             <a:endParaRPr lang="en-US" sz="1200" dirty="0"/>
           </a:p>

</xml_diff>